<commit_message>
Deploying to gh-pages from @ beom-park/beom-park.github.io@d73802643b888bef6ac1e5da1a90c8be51cc1056 🚀
</commit_message>
<xml_diff>
--- a/assets/img/publication_preview/jgcd_hierarchy.pptx
+++ b/assets/img/publication_preview/jgcd_hierarchy.pptx
@@ -3072,7 +3072,7 @@
         </p:nvSpPr>
         <p:spPr>
           <a:xfrm>
-            <a:off x="202466" y="248504"/>
+            <a:off x="245884" y="205523"/>
             <a:ext cx="2251432" cy="498598"/>
           </a:xfrm>
           <a:prstGeom prst="rect">
@@ -3182,6 +3182,9 @@
   <p:clrMapOvr>
     <a:masterClrMapping/>
   </p:clrMapOvr>
+  <p:transition advClick="0" advTm="2000">
+    <p:fade/>
+  </p:transition>
 </p:sld>
 </file>
 
@@ -3300,84 +3303,9 @@
   <p:clrMapOvr>
     <a:masterClrMapping/>
   </p:clrMapOvr>
-  <p:timing>
-    <p:tnLst>
-      <p:par>
-        <p:cTn id="1" dur="indefinite" restart="never" nodeType="tmRoot">
-          <p:childTnLst>
-            <p:seq concurrent="1" nextAc="seek">
-              <p:cTn id="2" dur="indefinite" nodeType="mainSeq">
-                <p:childTnLst>
-                  <p:par>
-                    <p:cTn id="3" fill="hold">
-                      <p:stCondLst>
-                        <p:cond delay="indefinite"/>
-                        <p:cond evt="onBegin" delay="0">
-                          <p:tn val="2"/>
-                        </p:cond>
-                      </p:stCondLst>
-                      <p:childTnLst>
-                        <p:par>
-                          <p:cTn id="4" fill="hold">
-                            <p:stCondLst>
-                              <p:cond delay="0"/>
-                            </p:stCondLst>
-                            <p:childTnLst>
-                              <p:par>
-                                <p:cTn id="5" presetID="1" presetClass="entr" presetSubtype="0" fill="hold" nodeType="withEffect">
-                                  <p:stCondLst>
-                                    <p:cond delay="0"/>
-                                  </p:stCondLst>
-                                  <p:childTnLst>
-                                    <p:set>
-                                      <p:cBhvr>
-                                        <p:cTn id="6" dur="1" fill="hold">
-                                          <p:stCondLst>
-                                            <p:cond delay="0"/>
-                                          </p:stCondLst>
-                                        </p:cTn>
-                                        <p:tgtEl>
-                                          <p:spTgt spid="2"/>
-                                        </p:tgtEl>
-                                        <p:attrNameLst>
-                                          <p:attrName>style.visibility</p:attrName>
-                                        </p:attrNameLst>
-                                      </p:cBhvr>
-                                      <p:to>
-                                        <p:strVal val="visible"/>
-                                      </p:to>
-                                    </p:set>
-                                  </p:childTnLst>
-                                </p:cTn>
-                              </p:par>
-                            </p:childTnLst>
-                          </p:cTn>
-                        </p:par>
-                      </p:childTnLst>
-                    </p:cTn>
-                  </p:par>
-                </p:childTnLst>
-              </p:cTn>
-              <p:prevCondLst>
-                <p:cond evt="onPrev" delay="0">
-                  <p:tgtEl>
-                    <p:sldTgt/>
-                  </p:tgtEl>
-                </p:cond>
-              </p:prevCondLst>
-              <p:nextCondLst>
-                <p:cond evt="onNext" delay="0">
-                  <p:tgtEl>
-                    <p:sldTgt/>
-                  </p:tgtEl>
-                </p:cond>
-              </p:nextCondLst>
-            </p:seq>
-          </p:childTnLst>
-        </p:cTn>
-      </p:par>
-    </p:tnLst>
-  </p:timing>
+  <p:transition advClick="0" advTm="2000">
+    <p:fade/>
+  </p:transition>
 </p:sld>
 </file>
 
@@ -3426,8 +3354,8 @@
         </p:blipFill>
         <p:spPr>
           <a:xfrm>
-            <a:off x="440238" y="305842"/>
-            <a:ext cx="1862724" cy="2308292"/>
+            <a:off x="520227" y="404964"/>
+            <a:ext cx="1702746" cy="2110048"/>
           </a:xfrm>
           <a:prstGeom prst="rect">
             <a:avLst/>
@@ -3666,196 +3594,9 @@
   <p:clrMapOvr>
     <a:masterClrMapping/>
   </p:clrMapOvr>
-  <p:timing>
-    <p:tnLst>
-      <p:par>
-        <p:cTn id="1" dur="indefinite" restart="never" nodeType="tmRoot">
-          <p:childTnLst>
-            <p:seq concurrent="1" nextAc="seek">
-              <p:cTn id="2" dur="indefinite" nodeType="mainSeq">
-                <p:childTnLst>
-                  <p:par>
-                    <p:cTn id="3" fill="hold">
-                      <p:stCondLst>
-                        <p:cond delay="indefinite"/>
-                        <p:cond evt="onBegin" delay="0">
-                          <p:tn val="2"/>
-                        </p:cond>
-                      </p:stCondLst>
-                      <p:childTnLst>
-                        <p:par>
-                          <p:cTn id="4" fill="hold">
-                            <p:stCondLst>
-                              <p:cond delay="0"/>
-                            </p:stCondLst>
-                            <p:childTnLst>
-                              <p:par>
-                                <p:cTn id="5" presetID="1" presetClass="entr" presetSubtype="0" fill="hold" nodeType="withEffect">
-                                  <p:stCondLst>
-                                    <p:cond delay="0"/>
-                                  </p:stCondLst>
-                                  <p:childTnLst>
-                                    <p:set>
-                                      <p:cBhvr>
-                                        <p:cTn id="6" dur="1" fill="hold">
-                                          <p:stCondLst>
-                                            <p:cond delay="0"/>
-                                          </p:stCondLst>
-                                        </p:cTn>
-                                        <p:tgtEl>
-                                          <p:spTgt spid="10"/>
-                                        </p:tgtEl>
-                                        <p:attrNameLst>
-                                          <p:attrName>style.visibility</p:attrName>
-                                        </p:attrNameLst>
-                                      </p:cBhvr>
-                                      <p:to>
-                                        <p:strVal val="visible"/>
-                                      </p:to>
-                                    </p:set>
-                                  </p:childTnLst>
-                                </p:cTn>
-                              </p:par>
-                              <p:par>
-                                <p:cTn id="7" presetID="1" presetClass="entr" presetSubtype="0" fill="hold" grpId="0" nodeType="withEffect">
-                                  <p:stCondLst>
-                                    <p:cond delay="0"/>
-                                  </p:stCondLst>
-                                  <p:childTnLst>
-                                    <p:set>
-                                      <p:cBhvr>
-                                        <p:cTn id="8" dur="1" fill="hold">
-                                          <p:stCondLst>
-                                            <p:cond delay="0"/>
-                                          </p:stCondLst>
-                                        </p:cTn>
-                                        <p:tgtEl>
-                                          <p:spTgt spid="15"/>
-                                        </p:tgtEl>
-                                        <p:attrNameLst>
-                                          <p:attrName>style.visibility</p:attrName>
-                                        </p:attrNameLst>
-                                      </p:cBhvr>
-                                      <p:to>
-                                        <p:strVal val="visible"/>
-                                      </p:to>
-                                    </p:set>
-                                  </p:childTnLst>
-                                </p:cTn>
-                              </p:par>
-                              <p:par>
-                                <p:cTn id="9" presetID="1" presetClass="entr" presetSubtype="0" fill="hold" nodeType="withEffect">
-                                  <p:stCondLst>
-                                    <p:cond delay="0"/>
-                                  </p:stCondLst>
-                                  <p:childTnLst>
-                                    <p:set>
-                                      <p:cBhvr>
-                                        <p:cTn id="10" dur="1" fill="hold">
-                                          <p:stCondLst>
-                                            <p:cond delay="0"/>
-                                          </p:stCondLst>
-                                        </p:cTn>
-                                        <p:tgtEl>
-                                          <p:spTgt spid="11"/>
-                                        </p:tgtEl>
-                                        <p:attrNameLst>
-                                          <p:attrName>style.visibility</p:attrName>
-                                        </p:attrNameLst>
-                                      </p:cBhvr>
-                                      <p:to>
-                                        <p:strVal val="visible"/>
-                                      </p:to>
-                                    </p:set>
-                                  </p:childTnLst>
-                                </p:cTn>
-                              </p:par>
-                              <p:par>
-                                <p:cTn id="11" presetID="1" presetClass="entr" presetSubtype="0" fill="hold" nodeType="withEffect">
-                                  <p:stCondLst>
-                                    <p:cond delay="0"/>
-                                  </p:stCondLst>
-                                  <p:childTnLst>
-                                    <p:set>
-                                      <p:cBhvr>
-                                        <p:cTn id="12" dur="1" fill="hold">
-                                          <p:stCondLst>
-                                            <p:cond delay="0"/>
-                                          </p:stCondLst>
-                                        </p:cTn>
-                                        <p:tgtEl>
-                                          <p:spTgt spid="13"/>
-                                        </p:tgtEl>
-                                        <p:attrNameLst>
-                                          <p:attrName>style.visibility</p:attrName>
-                                        </p:attrNameLst>
-                                      </p:cBhvr>
-                                      <p:to>
-                                        <p:strVal val="visible"/>
-                                      </p:to>
-                                    </p:set>
-                                  </p:childTnLst>
-                                </p:cTn>
-                              </p:par>
-                              <p:par>
-                                <p:cTn id="13" presetID="1" presetClass="entr" presetSubtype="0" fill="hold" grpId="0" nodeType="withEffect">
-                                  <p:stCondLst>
-                                    <p:cond delay="0"/>
-                                  </p:stCondLst>
-                                  <p:childTnLst>
-                                    <p:set>
-                                      <p:cBhvr>
-                                        <p:cTn id="14" dur="1" fill="hold">
-                                          <p:stCondLst>
-                                            <p:cond delay="0"/>
-                                          </p:stCondLst>
-                                        </p:cTn>
-                                        <p:tgtEl>
-                                          <p:spTgt spid="14"/>
-                                        </p:tgtEl>
-                                        <p:attrNameLst>
-                                          <p:attrName>style.visibility</p:attrName>
-                                        </p:attrNameLst>
-                                      </p:cBhvr>
-                                      <p:to>
-                                        <p:strVal val="visible"/>
-                                      </p:to>
-                                    </p:set>
-                                  </p:childTnLst>
-                                </p:cTn>
-                              </p:par>
-                            </p:childTnLst>
-                          </p:cTn>
-                        </p:par>
-                      </p:childTnLst>
-                    </p:cTn>
-                  </p:par>
-                </p:childTnLst>
-              </p:cTn>
-              <p:prevCondLst>
-                <p:cond evt="onPrev" delay="0">
-                  <p:tgtEl>
-                    <p:sldTgt/>
-                  </p:tgtEl>
-                </p:cond>
-              </p:prevCondLst>
-              <p:nextCondLst>
-                <p:cond evt="onNext" delay="0">
-                  <p:tgtEl>
-                    <p:sldTgt/>
-                  </p:tgtEl>
-                </p:cond>
-              </p:nextCondLst>
-            </p:seq>
-          </p:childTnLst>
-        </p:cTn>
-      </p:par>
-    </p:tnLst>
-    <p:bldLst>
-      <p:bldP spid="14" grpId="0"/>
-      <p:bldP spid="15" grpId="0"/>
-    </p:bldLst>
-  </p:timing>
+  <p:transition advClick="0" advTm="2000">
+    <p:fade/>
+  </p:transition>
 </p:sld>
 </file>
 

</xml_diff>